<commit_message>
Handover deck: add universes/baskets slide; correct model description
- New slide "The selectable universes & baskets": the three model
  portfolios (Core 9 / Expanded 21 / Extended 40) with token lists, the
  six thematic baskets, and the risk-profile × allocation-mode selectors.
- Correct "How the allocation is built": replace the loose "momentum,
  value, quality" wording with the real value-accrual signals (valuation
  FDV/fees & FDV/TVL, fee revenue, dilution, buybacks + sector-tailored
  signals incl. price momentum & dev activity).
- Note that Fundamental (factor-score weighted) is the default mode.

Deck is now 27 slides.

Co-Authored-By: Claude Opus 4.8 <noreply@anthropic.com>
</commit_message>
<xml_diff>
--- a/handover/Teroxx_Portfolio_App_Handover.pptx
+++ b/handover/Teroxx_Portfolio_App_Handover.pptx
@@ -36456,7 +36456,27 @@
                 <a:latin typeface="Söhne"/>
                 <a:cs typeface="Söhne"/>
               </a:rPr>
-              <a:t>(Standard = market-cap weighted · Fundamental = factor-score weighted).   The full research model scores 79 tokens; the 40-token union is what the firm can acquire today.</a:t>
+              <a:t>(Standard = market-cap weighted · </a:t>
+            </a:r>
+            <a:r>
+              <a:rPr sz="1050" b="1" i="0">
+                <a:solidFill>
+                  <a:srgbClr val="0E1430"/>
+                </a:solidFill>
+                <a:latin typeface="Söhne Halbfett"/>
+                <a:cs typeface="Söhne Halbfett"/>
+              </a:rPr>
+              <a:t>Fundamental = factor-score weighted, the default</a:t>
+            </a:r>
+            <a:r>
+              <a:rPr sz="1050" b="0" i="0">
+                <a:solidFill>
+                  <a:srgbClr val="4A5170"/>
+                </a:solidFill>
+                <a:latin typeface="Söhne"/>
+                <a:cs typeface="Söhne"/>
+              </a:rPr>
+              <a:t>).   The full research model scores 79 tokens; the 40-token union is what the firm can acquire today.</a:t>
             </a:r>
           </a:p>
         </p:txBody>
@@ -37141,7 +37161,7 @@
                 <a:latin typeface="Söhne"/>
                 <a:cs typeface="Söhne"/>
               </a:rPr>
-              <a:t>5-factor model (momentum, value, quality, and more)</a:t>
+              <a:t>Value-accrual signals: valuation (FDV/fees, FDV/TVL), fee revenue, dilution, buybacks</a:t>
             </a:r>
           </a:p>
           <a:p>
@@ -37174,7 +37194,7 @@
                 <a:latin typeface="Söhne"/>
                 <a:cs typeface="Söhne"/>
               </a:rPr>
-              <a:t>10-factor fundamental model for deeper diligence</a:t>
+              <a:t>Sector-tailored signals incl. price momentum &amp; developer activity</a:t>
             </a:r>
           </a:p>
           <a:p>
@@ -37207,7 +37227,7 @@
                 <a:latin typeface="Söhne"/>
                 <a:cs typeface="Söhne"/>
               </a:rPr>
-              <a:t>Live inputs: dev activity, TVL, funding, supply change</a:t>
+              <a:t>Every signal computed live from market &amp; on-chain data</a:t>
             </a:r>
           </a:p>
         </p:txBody>

</xml_diff>

<commit_message>
Handover: correct DB durability framing (verify backend, not "ephemeral SQLite")
The prior text asserted the app runs on ephemeral SQLite with a "durability
gap". That was an over-inference from render.yaml (which omits any
dashboard-set DATABASE_URL). The app is wired for Postgres (psycopg2-binary)
and may already use a managed Postgres via a dashboard env var.

Reframed across the Status, Where-it-lives, Data & persistence and
Credentials slides + the runbook: confirm the current backend in the Render
dashboard; the app supports managed Postgres via DATABASE_URL; standardise
the Teroxx deployment on managed Postgres (RDS). Kept the accurate note that
client data is mostly test/throwaway, so a fresh DB is fine.

Co-Authored-By: Claude Opus 4.8 <noreply@anthropic.com>
</commit_message>
<xml_diff>
--- a/handover/Teroxx_Portfolio_App_Handover.pptx
+++ b/handover/Teroxx_Portfolio_App_Handover.pptx
@@ -5030,7 +5030,7 @@
                 <a:latin typeface="Söhne Halbfett"/>
                 <a:cs typeface="Söhne Halbfett"/>
               </a:rPr>
-              <a:t>Data is not durable today — </a:t>
+              <a:t>Confirm the DB backend — </a:t>
             </a:r>
             <a:r>
               <a:rPr sz="1150" b="0" i="0">
@@ -5040,7 +5040,7 @@
                 <a:latin typeface="Söhne"/>
                 <a:cs typeface="Söhne"/>
               </a:rPr>
-              <a:t>runs SQLite on Render's free tier, whose disk resets on restart. Managed Postgres fixes this (Section 4).</a:t>
+              <a:t>the app supports managed Postgres via DATABASE_URL; verify in the Render dashboard, and put the Teroxx deployment on managed Postgres (Section 4).</a:t>
             </a:r>
           </a:p>
           <a:p>
@@ -6484,7 +6484,7 @@
                 <a:latin typeface="Söhne"/>
                 <a:cs typeface="Söhne"/>
               </a:rPr>
-              <a:t>New managed Postgres for durable client data</a:t>
+              <a:t>A Teroxx-managed Postgres (RDS); verify current backend</a:t>
             </a:r>
           </a:p>
         </p:txBody>
@@ -10068,12 +10068,12 @@
             <a:r>
               <a:rPr sz="1100" b="1" i="0" spc="150">
                 <a:solidFill>
-                  <a:srgbClr val="D06643"/>
+                  <a:srgbClr val="0B688C"/>
                 </a:solidFill>
                 <a:latin typeface="Söhne Halbfett"/>
                 <a:cs typeface="Söhne Halbfett"/>
               </a:rPr>
-              <a:t>THE DURABILITY GAP</a:t>
+              <a:t>CONFIRM THE BACKEND</a:t>
             </a:r>
           </a:p>
         </p:txBody>
@@ -10119,7 +10119,7 @@
                 <a:latin typeface="Söhne"/>
                 <a:cs typeface="Söhne"/>
               </a:rPr>
-              <a:t>Today no </a:t>
+              <a:t>The app reads </a:t>
             </a:r>
             <a:r>
               <a:rPr sz="1200" b="1" i="0">
@@ -10139,12 +10139,12 @@
                 <a:latin typeface="Söhne"/>
                 <a:cs typeface="Söhne"/>
               </a:rPr>
-              <a:t> is set, so the app uses SQLite on Render's free tier — whose filesystem is </a:t>
+              <a:t> at startup. If it points at a managed Postgres (likely set in the Render dashboard), data is durable. If it is unset, the app falls back to SQLite on Render's free tier, whose disk is </a:t>
             </a:r>
             <a:r>
               <a:rPr sz="1200" b="1" i="0">
                 <a:solidFill>
-                  <a:srgbClr val="C0432A"/>
+                  <a:srgbClr val="D06643"/>
                 </a:solidFill>
                 <a:latin typeface="Söhne Halbfett"/>
                 <a:cs typeface="Söhne Halbfett"/>
@@ -10159,7 +10159,7 @@
                 <a:latin typeface="Söhne"/>
                 <a:cs typeface="Söhne"/>
               </a:rPr>
-              <a:t>. It resets on every deploy and periodic restart.</a:t>
+              <a:t>.</a:t>
             </a:r>
           </a:p>
           <a:p>
@@ -10205,7 +10205,7 @@
                 <a:latin typeface="Söhne Halbfett"/>
                 <a:cs typeface="Söhne Halbfett"/>
               </a:rPr>
-              <a:t>Consequence: </a:t>
+              <a:t>Action: </a:t>
             </a:r>
             <a:r>
               <a:rPr sz="1200" b="0" i="0">
@@ -10215,7 +10215,7 @@
                 <a:latin typeface="Söhne"/>
                 <a:cs typeface="Söhne"/>
               </a:rPr>
-              <a:t>client records entered in the CRM are not guaranteed to survive a restart. In practice the app is used to build allocations and proposals on the fly, which do not depend on stored state.</a:t>
+              <a:t>confirm the current backend in the Render dashboard. Client data is mostly test/throwaway, so this is not blocking — a fresh database is fine.</a:t>
             </a:r>
           </a:p>
           <a:p>
@@ -10261,7 +10261,7 @@
                 <a:latin typeface="Söhne Halbfett"/>
                 <a:cs typeface="Söhne Halbfett"/>
               </a:rPr>
-              <a:t>The fix: </a:t>
+              <a:t>For Teroxx: </a:t>
             </a:r>
             <a:r>
               <a:rPr sz="1200" b="0" i="0">
@@ -10271,7 +10271,7 @@
                 <a:latin typeface="Söhne"/>
                 <a:cs typeface="Söhne"/>
               </a:rPr>
-              <a:t>provision a managed PostgreSQL and set DATABASE_URL. The code already supports it — no changes needed. This is step 2 of the migration runbook.</a:t>
+              <a:t>deploy on a managed Postgres (RDS) with DATABASE_URL set, and enable backups. The code already supports it — no changes needed (step 2 of the runbook).</a:t>
             </a:r>
           </a:p>
         </p:txBody>
@@ -24190,7 +24190,7 @@
                 <a:latin typeface="Söhne"/>
                 <a:cs typeface="Söhne"/>
               </a:rPr>
-              <a:t>Because the current deployment uses ephemeral SQLite, there is likely </a:t>
+              <a:t>Client data is </a:t>
             </a:r>
             <a:r>
               <a:rPr sz="1200" b="1" i="0">
@@ -24200,7 +24200,7 @@
                 <a:latin typeface="Söhne Halbfett"/>
                 <a:cs typeface="Söhne Halbfett"/>
               </a:rPr>
-              <a:t>little or no durable client data</a:t>
+              <a:t>mostly test / throwaway</a:t>
             </a:r>
             <a:r>
               <a:rPr sz="1200" b="0" i="0">
@@ -24210,7 +24210,7 @@
                 <a:latin typeface="Söhne"/>
                 <a:cs typeface="Söhne"/>
               </a:rPr>
-              <a:t> to migrate — clients are typically re-entered as needed.</a:t>
+              <a:t>, so migration can start with a fresh Teroxx database — clients are re-entered as needed.</a:t>
             </a:r>
           </a:p>
           <a:p>
@@ -24256,7 +24256,7 @@
                 <a:latin typeface="Söhne Halbfett"/>
                 <a:cs typeface="Söhne Halbfett"/>
               </a:rPr>
-              <a:t>If any records must be preserved: </a:t>
+              <a:t>If anything must be kept: </a:t>
             </a:r>
             <a:r>
               <a:rPr sz="1200" b="0" i="0">
@@ -24266,7 +24266,7 @@
                 <a:latin typeface="Söhne"/>
                 <a:cs typeface="Söhne"/>
               </a:rPr>
-              <a:t>export the current SQLite tables (Client, ClientLot, Scenario) and import them into the new Postgres before cut-over. The schema is identical — SQLAlchemy creates it automatically.</a:t>
+              <a:t>confirm the current backend, then dump it (Postgres or SQLite) and restore into the new Teroxx Postgres before cut-over. The schema is identical — SQLAlchemy creates it automatically.</a:t>
             </a:r>
           </a:p>
           <a:p>
@@ -24322,7 +24322,7 @@
                 <a:latin typeface="Söhne"/>
                 <a:cs typeface="Söhne"/>
               </a:rPr>
-              <a:t>with managed Postgres, enable automated daily backups. Client data then survives restarts and is recoverable.</a:t>
+              <a:t>managed Postgres + automated daily backups keeps client data durable and recoverable.</a:t>
             </a:r>
           </a:p>
         </p:txBody>

</xml_diff>